<commit_message>
Add Blue Halo presentation slide
</commit_message>
<xml_diff>
--- a/docs/Presentation-2026-May/BIMGUARD_AI_FMP_Presentation.pptx
+++ b/docs/Presentation-2026-May/BIMGUARD_AI_FMP_Presentation.pptx
@@ -22,6 +22,7 @@
     <p:sldId id="270" r:id="rId16"/>
     <p:sldId id="271" r:id="rId17"/>
     <p:sldId id="272" r:id="rId18"/>
+    <p:sldId id="279" r:id="rId30"/>
     <p:sldId id="273" r:id="rId19"/>
     <p:sldId id="274" r:id="rId20"/>
     <p:sldId id="275" r:id="rId21"/>
@@ -10828,6 +10829,966 @@
 </file>
 
 <file path=ppt/slides/slide18.xml><?xml version="1.0" encoding="utf-8"?>
+<p:sld xmlns:a="http://schemas.openxmlformats.org/drawingml/2006/main" xmlns:p="http://schemas.openxmlformats.org/presentationml/2006/main" xmlns:r="http://schemas.openxmlformats.org/officeDocument/2006/relationships">
+  <p:cSld>
+    <p:spTree>
+      <p:nvGrpSpPr>
+        <p:cNvPr id="1" name=""/>
+        <p:cNvGrpSpPr/>
+        <p:nvPr/>
+      </p:nvGrpSpPr>
+      <p:grpSpPr/>
+      <p:sp>
+        <p:nvSpPr>
+          <p:cNvPr id="2" name="Shape 0"/>
+          <p:cNvSpPr/>
+          <p:nvPr/>
+        </p:nvSpPr>
+        <p:spPr>
+          <a:xfrm>
+            <a:off x="0" y="0"/>
+            <a:ext cx="109728" cy="5143500"/>
+          </a:xfrm>
+          <a:prstGeom prst="rect">
+            <a:avLst/>
+          </a:prstGeom>
+          <a:solidFill>
+            <a:srgbClr val="1F3864"/>
+          </a:solidFill>
+          <a:ln w="12700">
+            <a:solidFill>
+              <a:srgbClr val="1F3864"/>
+            </a:solidFill>
+            <a:prstDash val="solid"/>
+          </a:ln>
+        </p:spPr>
+      </p:sp>
+      <p:sp>
+        <p:nvSpPr>
+          <p:cNvPr id="3" name="Text 1"/>
+          <p:cNvSpPr/>
+          <p:nvPr/>
+        </p:nvSpPr>
+        <p:spPr>
+          <a:xfrm>
+            <a:off x="274320" y="256032"/>
+            <a:ext cx="8595360" cy="502920"/>
+          </a:xfrm>
+          <a:prstGeom prst="rect">
+            <a:avLst/>
+          </a:prstGeom>
+          <a:noFill/>
+          <a:ln/>
+        </p:spPr>
+        <p:txBody>
+          <a:bodyPr wrap="square" lIns="0" tIns="0" rIns="0" bIns="0" rtlCol="0" anchor="ctr"/>
+          <a:lstStyle/>
+          <a:p>
+            <a:pPr indent="0" marL="0">
+              <a:buNone/>
+            </a:pPr>
+            <a:r>
+              <a:rPr lang="en-US" sz="2600" b="1" dirty="0">
+                <a:solidFill>
+                  <a:srgbClr val="1F3864"/>
+                </a:solidFill>
+                <a:latin typeface="Calibri" pitchFamily="34" charset="0"/>
+                <a:ea typeface="Calibri" pitchFamily="34" charset="-122"/>
+                <a:cs typeface="Calibri" pitchFamily="34" charset="-120"/>
+              </a:rPr>
+              <a:t>Blue Halo results — hospital MEP case study</a:t>
+            </a:r>
+            <a:endParaRPr lang="en-US" sz="2600" dirty="0"/>
+          </a:p>
+        </p:txBody>
+      </p:sp>
+      <p:sp>
+        <p:nvSpPr>
+          <p:cNvPr id="4" name="Text 2"/>
+          <p:cNvSpPr/>
+          <p:nvPr/>
+        </p:nvSpPr>
+        <p:spPr>
+          <a:xfrm>
+            <a:off x="274320" y="749808"/>
+            <a:ext cx="8595360" cy="292608"/>
+          </a:xfrm>
+          <a:prstGeom prst="rect">
+            <a:avLst/>
+          </a:prstGeom>
+          <a:noFill/>
+          <a:ln/>
+        </p:spPr>
+        <p:txBody>
+          <a:bodyPr wrap="square" lIns="0" tIns="0" rIns="0" bIns="0" rtlCol="0" anchor="ctr"/>
+          <a:lstStyle/>
+          <a:p>
+            <a:pPr indent="0" marL="0">
+              <a:buNone/>
+            </a:pPr>
+            <a:r>
+              <a:rPr lang="en-US" sz="1300" dirty="0">
+                <a:solidFill>
+                  <a:srgbClr val="8896A6"/>
+                </a:solidFill>
+                <a:latin typeface="Calibri" pitchFamily="34" charset="0"/>
+                <a:ea typeface="Calibri" pitchFamily="34" charset="-122"/>
+                <a:cs typeface="Calibri" pitchFamily="34" charset="-120"/>
+              </a:rPr>
+              <a:t>Hospital plant corridor, 3.5 m soffit height  ·  γa = 1.5  ·  seismic demand 0.35  ·  one run per brace family</a:t>
+            </a:r>
+            <a:endParaRPr lang="en-US" sz="1300" dirty="0"/>
+          </a:p>
+        </p:txBody>
+      </p:sp>
+      <p:sp>
+        <p:nvSpPr>
+          <p:cNvPr id="5" name="Shape 3"/>
+          <p:cNvSpPr/>
+          <p:nvPr/>
+        </p:nvSpPr>
+        <p:spPr>
+          <a:xfrm>
+            <a:off x="274320" y="1078992"/>
+            <a:ext cx="8595360" cy="20117"/>
+          </a:xfrm>
+          <a:prstGeom prst="rect">
+            <a:avLst/>
+          </a:prstGeom>
+          <a:solidFill>
+            <a:srgbClr val="DEEAF1"/>
+          </a:solidFill>
+          <a:ln w="12700">
+            <a:solidFill>
+              <a:srgbClr val="DEEAF1"/>
+            </a:solidFill>
+            <a:prstDash val="solid"/>
+          </a:ln>
+        </p:spPr>
+      </p:sp>
+      <p:sp>
+        <p:nvSpPr>
+          <p:cNvPr id="6" name="Shape 4"/>
+          <p:cNvSpPr/>
+          <p:nvPr/>
+        </p:nvSpPr>
+        <p:spPr>
+          <a:xfrm>
+            <a:off x="228600" y="1234440"/>
+            <a:ext cx="1965960" cy="1325880"/>
+          </a:xfrm>
+          <a:prstGeom prst="rect">
+            <a:avLst/>
+          </a:prstGeom>
+          <a:solidFill>
+            <a:srgbClr val="FFFFFF"/>
+          </a:solidFill>
+          <a:ln w="12700">
+            <a:solidFill>
+              <a:srgbClr val="DEEAF1"/>
+            </a:solidFill>
+            <a:prstDash val="solid"/>
+          </a:ln>
+          <a:effectLst>
+            <a:outerShdw sx="100000" sy="100000" kx="0" ky="0" algn="bl" rotWithShape="0" blurRad="101600" dist="38100" dir="8100000">
+              <a:srgbClr val="000000">
+                <a:alpha val="12000"/>
+              </a:srgbClr>
+            </a:outerShdw>
+          </a:effectLst>
+        </p:spPr>
+      </p:sp>
+      <p:sp>
+        <p:nvSpPr>
+          <p:cNvPr id="7" name="Shape 5"/>
+          <p:cNvSpPr/>
+          <p:nvPr/>
+        </p:nvSpPr>
+        <p:spPr>
+          <a:xfrm>
+            <a:off x="228600" y="1234440"/>
+            <a:ext cx="1965960" cy="73152"/>
+          </a:xfrm>
+          <a:prstGeom prst="rect">
+            <a:avLst/>
+          </a:prstGeom>
+          <a:solidFill>
+            <a:srgbClr val="A32D2D"/>
+          </a:solidFill>
+          <a:ln w="12700">
+            <a:solidFill>
+              <a:srgbClr val="A32D2D"/>
+            </a:solidFill>
+            <a:prstDash val="solid"/>
+          </a:ln>
+        </p:spPr>
+      </p:sp>
+      <p:sp>
+        <p:nvSpPr>
+          <p:cNvPr id="8" name="Text 6"/>
+          <p:cNvSpPr/>
+          <p:nvPr/>
+        </p:nvSpPr>
+        <p:spPr>
+          <a:xfrm>
+            <a:off x="320040" y="1399032"/>
+            <a:ext cx="1783080" cy="689458"/>
+          </a:xfrm>
+          <a:prstGeom prst="rect">
+            <a:avLst/>
+          </a:prstGeom>
+          <a:noFill/>
+          <a:ln/>
+        </p:spPr>
+        <p:txBody>
+          <a:bodyPr wrap="square" lIns="0" tIns="0" rIns="0" bIns="0" rtlCol="0" anchor="ctr"/>
+          <a:lstStyle/>
+          <a:p>
+            <a:pPr algn="ctr" indent="0" marL="0">
+              <a:buNone/>
+            </a:pPr>
+            <a:r>
+              <a:rPr lang="en-US" sz="3600" b="1" dirty="0">
+                <a:solidFill>
+                  <a:srgbClr val="A32D2D"/>
+                </a:solidFill>
+                <a:latin typeface="Calibri" pitchFamily="34" charset="0"/>
+                <a:ea typeface="Calibri" pitchFamily="34" charset="-122"/>
+                <a:cs typeface="Calibri" pitchFamily="34" charset="-120"/>
+              </a:rPr>
+              <a:t>380 mm</a:t>
+            </a:r>
+            <a:endParaRPr lang="en-US" sz="3600" dirty="0"/>
+          </a:p>
+        </p:txBody>
+      </p:sp>
+      <p:sp>
+        <p:nvSpPr>
+          <p:cNvPr id="9" name="Text 7"/>
+          <p:cNvSpPr/>
+          <p:nvPr/>
+        </p:nvSpPr>
+        <p:spPr>
+          <a:xfrm>
+            <a:off x="320040" y="2083003"/>
+            <a:ext cx="1783080" cy="397764"/>
+          </a:xfrm>
+          <a:prstGeom prst="rect">
+            <a:avLst/>
+          </a:prstGeom>
+          <a:noFill/>
+          <a:ln/>
+        </p:spPr>
+        <p:txBody>
+          <a:bodyPr wrap="square" lIns="0" tIns="0" rIns="0" bIns="0" rtlCol="0" anchor="t"/>
+          <a:lstStyle/>
+          <a:p>
+            <a:pPr algn="ctr" indent="0" marL="0">
+              <a:buNone/>
+            </a:pPr>
+            <a:r>
+              <a:rPr lang="en-US" sz="1100" dirty="0">
+                <a:solidFill>
+                  <a:srgbClr val="8896A6"/>
+                </a:solidFill>
+                <a:latin typeface="Calibri" pitchFamily="34" charset="0"/>
+                <a:ea typeface="Calibri" pitchFamily="34" charset="-122"/>
+                <a:cs typeface="Calibri" pitchFamily="34" charset="-120"/>
+              </a:rPr>
+              <a:t>Angle iron Halo</a:t>
+            </a:r>
+            <a:endParaRPr lang="en-US" sz="1100" dirty="0"/>
+          </a:p>
+          <a:p>
+            <a:pPr algn="ctr" indent="0" marL="0">
+              <a:buNone/>
+            </a:pPr>
+            <a:r>
+              <a:rPr lang="en-US" sz="1100" dirty="0">
+                <a:solidFill>
+                  <a:srgbClr val="8896A6"/>
+                </a:solidFill>
+                <a:latin typeface="Calibri" pitchFamily="34" charset="0"/>
+                <a:ea typeface="Calibri" pitchFamily="34" charset="-122"/>
+                <a:cs typeface="Calibri" pitchFamily="34" charset="-120"/>
+              </a:rPr>
+              <a:t>2 conflicts</a:t>
+            </a:r>
+            <a:endParaRPr lang="en-US" sz="1100" dirty="0"/>
+          </a:p>
+        </p:txBody>
+      </p:sp>
+      <p:sp>
+        <p:nvSpPr>
+          <p:cNvPr id="10" name="Shape 8"/>
+          <p:cNvSpPr/>
+          <p:nvPr/>
+        </p:nvSpPr>
+        <p:spPr>
+          <a:xfrm>
+            <a:off x="2359152" y="1234440"/>
+            <a:ext cx="1965960" cy="1325880"/>
+          </a:xfrm>
+          <a:prstGeom prst="rect">
+            <a:avLst/>
+          </a:prstGeom>
+          <a:solidFill>
+            <a:srgbClr val="FFFFFF"/>
+          </a:solidFill>
+          <a:ln w="12700">
+            <a:solidFill>
+              <a:srgbClr val="DEEAF1"/>
+            </a:solidFill>
+            <a:prstDash val="solid"/>
+          </a:ln>
+          <a:effectLst>
+            <a:outerShdw sx="100000" sy="100000" kx="0" ky="0" algn="bl" rotWithShape="0" blurRad="101600" dist="38100" dir="8100000">
+              <a:srgbClr val="000000">
+                <a:alpha val="12000"/>
+              </a:srgbClr>
+            </a:outerShdw>
+          </a:effectLst>
+        </p:spPr>
+      </p:sp>
+      <p:sp>
+        <p:nvSpPr>
+          <p:cNvPr id="11" name="Shape 9"/>
+          <p:cNvSpPr/>
+          <p:nvPr/>
+        </p:nvSpPr>
+        <p:spPr>
+          <a:xfrm>
+            <a:off x="2359152" y="1234440"/>
+            <a:ext cx="1965960" cy="73152"/>
+          </a:xfrm>
+          <a:prstGeom prst="rect">
+            <a:avLst/>
+          </a:prstGeom>
+          <a:solidFill>
+            <a:srgbClr val="B45309"/>
+          </a:solidFill>
+          <a:ln w="12700">
+            <a:solidFill>
+              <a:srgbClr val="C2510A"/>
+            </a:solidFill>
+            <a:prstDash val="solid"/>
+          </a:ln>
+        </p:spPr>
+      </p:sp>
+      <p:sp>
+        <p:nvSpPr>
+          <p:cNvPr id="12" name="Text 10"/>
+          <p:cNvSpPr/>
+          <p:nvPr/>
+        </p:nvSpPr>
+        <p:spPr>
+          <a:xfrm>
+            <a:off x="2450592" y="1399032"/>
+            <a:ext cx="1783080" cy="689458"/>
+          </a:xfrm>
+          <a:prstGeom prst="rect">
+            <a:avLst/>
+          </a:prstGeom>
+          <a:noFill/>
+          <a:ln/>
+        </p:spPr>
+        <p:txBody>
+          <a:bodyPr wrap="square" lIns="0" tIns="0" rIns="0" bIns="0" rtlCol="0" anchor="ctr"/>
+          <a:lstStyle/>
+          <a:p>
+            <a:pPr algn="ctr" indent="0" marL="0">
+              <a:buNone/>
+            </a:pPr>
+            <a:r>
+              <a:rPr lang="en-US" sz="3600" b="1" dirty="0">
+                <a:solidFill>
+                  <a:srgbClr val="C2510A"/>
+                </a:solidFill>
+                <a:latin typeface="Calibri" pitchFamily="34" charset="0"/>
+                <a:ea typeface="Calibri" pitchFamily="34" charset="-122"/>
+                <a:cs typeface="Calibri" pitchFamily="34" charset="-120"/>
+              </a:rPr>
+              <a:t>200 mm</a:t>
+            </a:r>
+            <a:endParaRPr lang="en-US" sz="3600" dirty="0"/>
+          </a:p>
+        </p:txBody>
+      </p:sp>
+      <p:sp>
+        <p:nvSpPr>
+          <p:cNvPr id="13" name="Text 11"/>
+          <p:cNvSpPr/>
+          <p:nvPr/>
+        </p:nvSpPr>
+        <p:spPr>
+          <a:xfrm>
+            <a:off x="2450592" y="2083003"/>
+            <a:ext cx="1783080" cy="397764"/>
+          </a:xfrm>
+          <a:prstGeom prst="rect">
+            <a:avLst/>
+          </a:prstGeom>
+          <a:noFill/>
+          <a:ln/>
+        </p:spPr>
+        <p:txBody>
+          <a:bodyPr wrap="square" lIns="0" tIns="0" rIns="0" bIns="0" rtlCol="0" anchor="t"/>
+          <a:lstStyle/>
+          <a:p>
+            <a:pPr algn="ctr" indent="0" marL="0">
+              <a:buNone/>
+            </a:pPr>
+            <a:r>
+              <a:rPr lang="en-US" sz="1100" dirty="0">
+                <a:solidFill>
+                  <a:srgbClr val="8896A6"/>
+                </a:solidFill>
+                <a:latin typeface="Calibri" pitchFamily="34" charset="0"/>
+                <a:ea typeface="Calibri" pitchFamily="34" charset="-122"/>
+                <a:cs typeface="Calibri" pitchFamily="34" charset="-120"/>
+              </a:rPr>
+              <a:t>Threaded rod Halo</a:t>
+            </a:r>
+            <a:endParaRPr lang="en-US" sz="1100" dirty="0"/>
+          </a:p>
+          <a:p>
+            <a:pPr algn="ctr" indent="0" marL="0">
+              <a:buNone/>
+            </a:pPr>
+            <a:r>
+              <a:rPr lang="en-US" sz="1100" dirty="0">
+                <a:solidFill>
+                  <a:srgbClr val="8896A6"/>
+                </a:solidFill>
+                <a:latin typeface="Calibri" pitchFamily="34" charset="0"/>
+                <a:ea typeface="Calibri" pitchFamily="34" charset="-122"/>
+                <a:cs typeface="Calibri" pitchFamily="34" charset="-120"/>
+              </a:rPr>
+              <a:t>1 conflict</a:t>
+            </a:r>
+            <a:endParaRPr lang="en-US" sz="1100" dirty="0"/>
+          </a:p>
+        </p:txBody>
+      </p:sp>
+      <p:sp>
+        <p:nvSpPr>
+          <p:cNvPr id="14" name="Shape 12"/>
+          <p:cNvSpPr/>
+          <p:nvPr/>
+        </p:nvSpPr>
+        <p:spPr>
+          <a:xfrm>
+            <a:off x="4489704" y="1234440"/>
+            <a:ext cx="1965960" cy="1325880"/>
+          </a:xfrm>
+          <a:prstGeom prst="rect">
+            <a:avLst/>
+          </a:prstGeom>
+          <a:solidFill>
+            <a:srgbClr val="FFFFFF"/>
+          </a:solidFill>
+          <a:ln w="12700">
+            <a:solidFill>
+              <a:srgbClr val="DEEAF1"/>
+            </a:solidFill>
+            <a:prstDash val="solid"/>
+          </a:ln>
+          <a:effectLst>
+            <a:outerShdw sx="100000" sy="100000" kx="0" ky="0" algn="bl" rotWithShape="0" blurRad="101600" dist="38100" dir="8100000">
+              <a:srgbClr val="000000">
+                <a:alpha val="12000"/>
+              </a:srgbClr>
+            </a:outerShdw>
+          </a:effectLst>
+        </p:spPr>
+      </p:sp>
+      <p:sp>
+        <p:nvSpPr>
+          <p:cNvPr id="15" name="Shape 13"/>
+          <p:cNvSpPr/>
+          <p:nvPr/>
+        </p:nvSpPr>
+        <p:spPr>
+          <a:xfrm>
+            <a:off x="4489704" y="1234440"/>
+            <a:ext cx="1965960" cy="73152"/>
+          </a:xfrm>
+          <a:prstGeom prst="rect">
+            <a:avLst/>
+          </a:prstGeom>
+          <a:solidFill>
+            <a:srgbClr val="1F3864"/>
+          </a:solidFill>
+          <a:ln w="12700">
+            <a:solidFill>
+              <a:srgbClr val="B45309"/>
+            </a:solidFill>
+            <a:prstDash val="solid"/>
+          </a:ln>
+        </p:spPr>
+      </p:sp>
+      <p:sp>
+        <p:nvSpPr>
+          <p:cNvPr id="16" name="Text 14"/>
+          <p:cNvSpPr/>
+          <p:nvPr/>
+        </p:nvSpPr>
+        <p:spPr>
+          <a:xfrm>
+            <a:off x="4581144" y="1399032"/>
+            <a:ext cx="1783080" cy="689458"/>
+          </a:xfrm>
+          <a:prstGeom prst="rect">
+            <a:avLst/>
+          </a:prstGeom>
+          <a:noFill/>
+          <a:ln/>
+        </p:spPr>
+        <p:txBody>
+          <a:bodyPr wrap="square" lIns="0" tIns="0" rIns="0" bIns="0" rtlCol="0" anchor="ctr"/>
+          <a:lstStyle/>
+          <a:p>
+            <a:pPr algn="ctr" indent="0" marL="0">
+              <a:buNone/>
+            </a:pPr>
+            <a:r>
+              <a:rPr lang="en-US" sz="3600" b="1" dirty="0">
+                <a:solidFill>
+                  <a:srgbClr val="1F3864"/>
+                </a:solidFill>
+                <a:latin typeface="Calibri" pitchFamily="34" charset="0"/>
+                <a:ea typeface="Calibri" pitchFamily="34" charset="-122"/>
+                <a:cs typeface="Calibri" pitchFamily="34" charset="-120"/>
+              </a:rPr>
+              <a:t>120 mm</a:t>
+            </a:r>
+            <a:endParaRPr lang="en-US" sz="3600" dirty="0"/>
+          </a:p>
+        </p:txBody>
+      </p:sp>
+      <p:sp>
+        <p:nvSpPr>
+          <p:cNvPr id="17" name="Text 15"/>
+          <p:cNvSpPr/>
+          <p:nvPr/>
+        </p:nvSpPr>
+        <p:spPr>
+          <a:xfrm>
+            <a:off x="4581144" y="2083003"/>
+            <a:ext cx="1783080" cy="397764"/>
+          </a:xfrm>
+          <a:prstGeom prst="rect">
+            <a:avLst/>
+          </a:prstGeom>
+          <a:noFill/>
+          <a:ln/>
+        </p:spPr>
+        <p:txBody>
+          <a:bodyPr wrap="square" lIns="0" tIns="0" rIns="0" bIns="0" rtlCol="0" anchor="t"/>
+          <a:lstStyle/>
+          <a:p>
+            <a:pPr algn="ctr" indent="0" marL="0">
+              <a:buNone/>
+            </a:pPr>
+            <a:r>
+              <a:rPr lang="en-US" sz="1100" dirty="0">
+                <a:solidFill>
+                  <a:srgbClr val="8896A6"/>
+                </a:solidFill>
+                <a:latin typeface="Calibri" pitchFamily="34" charset="0"/>
+                <a:ea typeface="Calibri" pitchFamily="34" charset="-122"/>
+                <a:cs typeface="Calibri" pitchFamily="34" charset="-120"/>
+              </a:rPr>
+              <a:t>Cable Halo</a:t>
+            </a:r>
+            <a:endParaRPr lang="en-US" sz="1100" dirty="0"/>
+          </a:p>
+          <a:p>
+            <a:pPr algn="ctr" indent="0" marL="0">
+              <a:buNone/>
+            </a:pPr>
+            <a:r>
+              <a:rPr lang="en-US" sz="1100" dirty="0">
+                <a:solidFill>
+                  <a:srgbClr val="8896A6"/>
+                </a:solidFill>
+                <a:latin typeface="Calibri" pitchFamily="34" charset="0"/>
+                <a:ea typeface="Calibri" pitchFamily="34" charset="-122"/>
+                <a:cs typeface="Calibri" pitchFamily="34" charset="-120"/>
+              </a:rPr>
+              <a:t>0 conflicts</a:t>
+            </a:r>
+            <a:endParaRPr lang="en-US" sz="1100" dirty="0"/>
+          </a:p>
+        </p:txBody>
+      </p:sp>
+      <p:sp>
+        <p:nvSpPr>
+          <p:cNvPr id="18" name="Shape 16"/>
+          <p:cNvSpPr/>
+          <p:nvPr/>
+        </p:nvSpPr>
+        <p:spPr>
+          <a:xfrm>
+            <a:off x="6620256" y="1234440"/>
+            <a:ext cx="1965960" cy="1325880"/>
+          </a:xfrm>
+          <a:prstGeom prst="rect">
+            <a:avLst/>
+          </a:prstGeom>
+          <a:solidFill>
+            <a:srgbClr val="FFFFFF"/>
+          </a:solidFill>
+          <a:ln w="12700">
+            <a:solidFill>
+              <a:srgbClr val="DEEAF1"/>
+            </a:solidFill>
+            <a:prstDash val="solid"/>
+          </a:ln>
+          <a:effectLst>
+            <a:outerShdw sx="100000" sy="100000" kx="0" ky="0" algn="bl" rotWithShape="0" blurRad="101600" dist="38100" dir="8100000">
+              <a:srgbClr val="000000">
+                <a:alpha val="12000"/>
+              </a:srgbClr>
+            </a:outerShdw>
+          </a:effectLst>
+        </p:spPr>
+      </p:sp>
+      <p:sp>
+        <p:nvSpPr>
+          <p:cNvPr id="19" name="Shape 17"/>
+          <p:cNvSpPr/>
+          <p:nvPr/>
+        </p:nvSpPr>
+        <p:spPr>
+          <a:xfrm>
+            <a:off x="6620256" y="1234440"/>
+            <a:ext cx="1965960" cy="73152"/>
+          </a:xfrm>
+          <a:prstGeom prst="rect">
+            <a:avLst/>
+          </a:prstGeom>
+          <a:solidFill>
+            <a:srgbClr val="1F3864"/>
+          </a:solidFill>
+          <a:ln w="12700">
+            <a:solidFill>
+              <a:srgbClr val="1F3864"/>
+            </a:solidFill>
+            <a:prstDash val="solid"/>
+          </a:ln>
+        </p:spPr>
+      </p:sp>
+      <p:sp>
+        <p:nvSpPr>
+          <p:cNvPr id="20" name="Text 18"/>
+          <p:cNvSpPr/>
+          <p:nvPr/>
+        </p:nvSpPr>
+        <p:spPr>
+          <a:xfrm>
+            <a:off x="6711696" y="1399032"/>
+            <a:ext cx="1783080" cy="689458"/>
+          </a:xfrm>
+          <a:prstGeom prst="rect">
+            <a:avLst/>
+          </a:prstGeom>
+          <a:noFill/>
+          <a:ln/>
+        </p:spPr>
+        <p:txBody>
+          <a:bodyPr wrap="square" lIns="0" tIns="0" rIns="0" bIns="0" rtlCol="0" anchor="ctr"/>
+          <a:lstStyle/>
+          <a:p>
+            <a:pPr algn="ctr" indent="0" marL="0">
+              <a:buNone/>
+            </a:pPr>
+            <a:r>
+              <a:rPr lang="en-US" sz="3600" b="1" dirty="0">
+                <a:solidFill>
+                  <a:srgbClr val="1F3864"/>
+                </a:solidFill>
+                <a:latin typeface="Calibri" pitchFamily="34" charset="0"/>
+                <a:ea typeface="Calibri" pitchFamily="34" charset="-122"/>
+                <a:cs typeface="Calibri" pitchFamily="34" charset="-120"/>
+              </a:rPr>
+              <a:t>12.2 m</a:t>
+            </a:r>
+            <a:endParaRPr lang="en-US" sz="3600" dirty="0"/>
+          </a:p>
+        </p:txBody>
+      </p:sp>
+      <p:sp>
+        <p:nvSpPr>
+          <p:cNvPr id="21" name="Text 19"/>
+          <p:cNvSpPr/>
+          <p:nvPr/>
+        </p:nvSpPr>
+        <p:spPr>
+          <a:xfrm>
+            <a:off x="6711696" y="2083003"/>
+            <a:ext cx="1783080" cy="397764"/>
+          </a:xfrm>
+          <a:prstGeom prst="rect">
+            <a:avLst/>
+          </a:prstGeom>
+          <a:noFill/>
+          <a:ln/>
+        </p:spPr>
+        <p:txBody>
+          <a:bodyPr wrap="square" lIns="0" tIns="0" rIns="0" bIns="0" rtlCol="0" anchor="t"/>
+          <a:lstStyle/>
+          <a:p>
+            <a:pPr algn="ctr" indent="0" marL="0">
+              <a:buNone/>
+            </a:pPr>
+            <a:r>
+              <a:rPr lang="en-US" sz="1100" dirty="0">
+                <a:solidFill>
+                  <a:srgbClr val="8896A6"/>
+                </a:solidFill>
+                <a:latin typeface="Calibri" pitchFamily="34" charset="0"/>
+                <a:ea typeface="Calibri" pitchFamily="34" charset="-122"/>
+                <a:cs typeface="Calibri" pitchFamily="34" charset="-120"/>
+              </a:rPr>
+              <a:t>Transverse spacing</a:t>
+            </a:r>
+            <a:endParaRPr lang="en-US" sz="1100" dirty="0"/>
+          </a:p>
+          <a:p>
+            <a:pPr algn="ctr" indent="0" marL="0">
+              <a:buNone/>
+            </a:pPr>
+            <a:r>
+              <a:rPr lang="en-US" sz="1100" dirty="0">
+                <a:solidFill>
+                  <a:srgbClr val="8896A6"/>
+                </a:solidFill>
+                <a:latin typeface="Calibri" pitchFamily="34" charset="0"/>
+                <a:ea typeface="Calibri" pitchFamily="34" charset="-122"/>
+                <a:cs typeface="Calibri" pitchFamily="34" charset="-120"/>
+              </a:rPr>
+              <a:t>NFPA 13 Ch. 18</a:t>
+            </a:r>
+            <a:endParaRPr lang="en-US" sz="1100" dirty="0"/>
+          </a:p>
+        </p:txBody>
+      </p:sp>
+      <p:sp>
+        <p:nvSpPr>
+          <p:cNvPr id="22" name="Shape 20"/>
+          <p:cNvSpPr/>
+          <p:nvPr/>
+        </p:nvSpPr>
+        <p:spPr>
+          <a:xfrm>
+            <a:off x="228600" y="2743200"/>
+            <a:ext cx="8686800" cy="713232"/>
+          </a:xfrm>
+          <a:prstGeom prst="rect">
+            <a:avLst/>
+          </a:prstGeom>
+          <a:solidFill>
+            <a:srgbClr val="DEEAF1"/>
+          </a:solidFill>
+          <a:ln w="12700">
+            <a:solidFill>
+              <a:srgbClr val="1F3864"/>
+            </a:solidFill>
+            <a:prstDash val="solid"/>
+          </a:ln>
+        </p:spPr>
+      </p:sp>
+      <p:sp>
+        <p:nvSpPr>
+          <p:cNvPr id="23" name="Text 21"/>
+          <p:cNvSpPr/>
+          <p:nvPr/>
+        </p:nvSpPr>
+        <p:spPr>
+          <a:xfrm>
+            <a:off x="365760" y="2743200"/>
+            <a:ext cx="1371600" cy="713232"/>
+          </a:xfrm>
+          <a:prstGeom prst="rect">
+            <a:avLst/>
+          </a:prstGeom>
+          <a:noFill/>
+          <a:ln/>
+        </p:spPr>
+        <p:txBody>
+          <a:bodyPr wrap="square" lIns="0" tIns="0" rIns="0" bIns="0" rtlCol="0" anchor="ctr"/>
+          <a:lstStyle/>
+          <a:p>
+            <a:pPr indent="0" marL="0">
+              <a:buNone/>
+            </a:pPr>
+            <a:r>
+              <a:rPr lang="en-US" sz="1300" b="1" dirty="0">
+                <a:solidFill>
+                  <a:srgbClr val="1F3864"/>
+                </a:solidFill>
+                <a:latin typeface="Calibri" pitchFamily="34" charset="0"/>
+                <a:ea typeface="Calibri" pitchFamily="34" charset="-122"/>
+                <a:cs typeface="Calibri" pitchFamily="34" charset="-120"/>
+              </a:rPr>
+              <a:t>Recommendation:</a:t>
+            </a:r>
+            <a:endParaRPr lang="en-US" sz="1300" dirty="0"/>
+          </a:p>
+        </p:txBody>
+      </p:sp>
+      <p:sp>
+        <p:nvSpPr>
+          <p:cNvPr id="24" name="Text 22"/>
+          <p:cNvSpPr/>
+          <p:nvPr/>
+        </p:nvSpPr>
+        <p:spPr>
+          <a:xfrm>
+            <a:off x="1737360" y="2743200"/>
+            <a:ext cx="7040880" cy="713232"/>
+          </a:xfrm>
+          <a:prstGeom prst="rect">
+            <a:avLst/>
+          </a:prstGeom>
+          <a:noFill/>
+          <a:ln/>
+        </p:spPr>
+        <p:txBody>
+          <a:bodyPr wrap="square" lIns="0" tIns="0" rIns="0" bIns="0" rtlCol="0" anchor="ctr"/>
+          <a:lstStyle/>
+          <a:p>
+            <a:pPr indent="0" marL="0">
+              <a:buNone/>
+            </a:pPr>
+            <a:r>
+              <a:rPr lang="en-US" sz="1150" dirty="0">
+                <a:solidFill>
+                  <a:srgbClr val="1F3864"/>
+                </a:solidFill>
+                <a:latin typeface="Calibri" pitchFamily="34" charset="0"/>
+                <a:ea typeface="Calibri" pitchFamily="34" charset="-122"/>
+                <a:cs typeface="Calibri" pitchFamily="34" charset="-120"/>
+              </a:rPr>
+              <a:t>Cable bracing — the only family that resolves the node set without a design change. Smallest footprint, clear of both the sprinkler main and the conduit.</a:t>
+            </a:r>
+            <a:endParaRPr lang="en-US" sz="1150" dirty="0"/>
+          </a:p>
+        </p:txBody>
+      </p:sp>
+      <p:sp>
+        <p:nvSpPr>
+          <p:cNvPr id="25" name="Text 23"/>
+          <p:cNvSpPr/>
+          <p:nvPr/>
+        </p:nvSpPr>
+        <p:spPr>
+          <a:xfrm>
+            <a:off x="228600" y="3657600"/>
+            <a:ext cx="8686800" cy="402336"/>
+          </a:xfrm>
+          <a:prstGeom prst="rect">
+            <a:avLst/>
+          </a:prstGeom>
+          <a:noFill/>
+          <a:ln/>
+        </p:spPr>
+        <p:txBody>
+          <a:bodyPr wrap="square" lIns="0" tIns="0" rIns="0" bIns="0" rtlCol="0" anchor="ctr"/>
+          <a:lstStyle/>
+          <a:p>
+            <a:pPr indent="0" marL="0">
+              <a:buNone/>
+            </a:pPr>
+            <a:r>
+              <a:rPr lang="en-US" sz="1100" i="1" dirty="0">
+                <a:solidFill>
+                  <a:srgbClr val="8896A6"/>
+                </a:solidFill>
+                <a:latin typeface="Calibri" pitchFamily="34" charset="0"/>
+                <a:ea typeface="Calibri" pitchFamily="34" charset="-122"/>
+                <a:cs typeface="Calibri" pitchFamily="34" charset="-120"/>
+              </a:rPr>
+              <a:t>Reserved at LOD 300, the conflict reaches the designer while ductwork and conduit can still be moved. Mehrbod et al. (2019) record a comparable reroute costing six weeks once services were installed.</a:t>
+            </a:r>
+            <a:endParaRPr lang="en-US" sz="1100" dirty="0"/>
+          </a:p>
+        </p:txBody>
+      </p:sp>
+      <p:sp>
+        <p:nvSpPr>
+          <p:cNvPr id="26" name="Shape 24"/>
+          <p:cNvSpPr/>
+          <p:nvPr/>
+        </p:nvSpPr>
+        <p:spPr>
+          <a:xfrm>
+            <a:off x="0" y="4892040"/>
+            <a:ext cx="9144000" cy="251460"/>
+          </a:xfrm>
+          <a:prstGeom prst="rect">
+            <a:avLst/>
+          </a:prstGeom>
+          <a:solidFill>
+            <a:srgbClr val="1F3864"/>
+          </a:solidFill>
+          <a:ln w="12700">
+            <a:solidFill>
+              <a:srgbClr val="1F3864"/>
+            </a:solidFill>
+            <a:prstDash val="solid"/>
+          </a:ln>
+        </p:spPr>
+      </p:sp>
+      <p:sp>
+        <p:nvSpPr>
+          <p:cNvPr id="27" name="Text 25"/>
+          <p:cNvSpPr/>
+          <p:nvPr/>
+        </p:nvSpPr>
+        <p:spPr>
+          <a:xfrm>
+            <a:off x="228600" y="4901184"/>
+            <a:ext cx="8686800" cy="228600"/>
+          </a:xfrm>
+          <a:prstGeom prst="rect">
+            <a:avLst/>
+          </a:prstGeom>
+          <a:noFill/>
+          <a:ln/>
+        </p:spPr>
+        <p:txBody>
+          <a:bodyPr wrap="square" lIns="0" tIns="0" rIns="0" bIns="0" rtlCol="0" anchor="ctr"/>
+          <a:lstStyle/>
+          <a:p>
+            <a:pPr indent="0" marL="0">
+              <a:buNone/>
+            </a:pPr>
+            <a:r>
+              <a:rPr lang="en-US" sz="850" dirty="0">
+                <a:solidFill>
+                  <a:srgbClr val="FFFFFF"/>
+                </a:solidFill>
+                <a:latin typeface="Calibri" pitchFamily="34" charset="0"/>
+                <a:ea typeface="Calibri" pitchFamily="34" charset="-122"/>
+                <a:cs typeface="Calibri" pitchFamily="34" charset="-120"/>
+              </a:rPr>
+              <a:t>BIMGUARD AI  |  Final Master Project  |  Zigurat Global Institute of Technology  |  Group 5</a:t>
+            </a:r>
+            <a:endParaRPr lang="en-US" sz="850" dirty="0"/>
+          </a:p>
+        </p:txBody>
+      </p:sp>
+    </p:spTree>
+  </p:cSld>
+  <p:clrMapOvr>
+    <a:masterClrMapping/>
+  </p:clrMapOvr>
+</p:sld>
+</file>
+
+<file path=ppt/slides/slide19.xml><?xml version="1.0" encoding="utf-8"?>
 <p:sld xmlns:a="http://schemas.openxmlformats.org/drawingml/2006/main" xmlns:r="http://schemas.openxmlformats.org/officeDocument/2006/relationships" xmlns:p="http://schemas.openxmlformats.org/presentationml/2006/main">
   <p:cSld name="Slide 18">
     <p:bg>
@@ -11384,635 +12345,6 @@
               <a:rPr lang="en-US" sz="850" dirty="0">
                 <a:solidFill>
                   <a:srgbClr val="8896A6"/>
-                </a:solidFill>
-                <a:latin typeface="Calibri" pitchFamily="34" charset="0"/>
-                <a:ea typeface="Calibri" pitchFamily="34" charset="-122"/>
-                <a:cs typeface="Calibri" pitchFamily="34" charset="-120"/>
-              </a:rPr>
-              <a:t>BIMGUARD AI  |  Final Master Project  |  Zigurat Global Institute of Technology  |  Group 5</a:t>
-            </a:r>
-            <a:endParaRPr lang="en-US" sz="850" dirty="0"/>
-          </a:p>
-        </p:txBody>
-      </p:sp>
-    </p:spTree>
-  </p:cSld>
-  <p:clrMapOvr>
-    <a:masterClrMapping/>
-  </p:clrMapOvr>
-</p:sld>
-</file>
-
-<file path=ppt/slides/slide19.xml><?xml version="1.0" encoding="utf-8"?>
-<p:sld xmlns:a="http://schemas.openxmlformats.org/drawingml/2006/main" xmlns:r="http://schemas.openxmlformats.org/officeDocument/2006/relationships" xmlns:p="http://schemas.openxmlformats.org/presentationml/2006/main">
-  <p:cSld name="Slide 19">
-    <p:bg>
-      <p:bgPr>
-        <a:solidFill>
-          <a:srgbClr val="F4F6FB"/>
-        </a:solidFill>
-      </p:bgPr>
-    </p:bg>
-    <p:spTree>
-      <p:nvGrpSpPr>
-        <p:cNvPr id="1" name=""/>
-        <p:cNvGrpSpPr/>
-        <p:nvPr/>
-      </p:nvGrpSpPr>
-      <p:grpSpPr>
-        <a:xfrm>
-          <a:off x="0" y="0"/>
-          <a:ext cx="0" cy="0"/>
-          <a:chOff x="0" y="0"/>
-          <a:chExt cx="0" cy="0"/>
-        </a:xfrm>
-      </p:grpSpPr>
-      <p:sp>
-        <p:nvSpPr>
-          <p:cNvPr id="2" name="Shape 0"/>
-          <p:cNvSpPr/>
-          <p:nvPr/>
-        </p:nvSpPr>
-        <p:spPr>
-          <a:xfrm>
-            <a:off x="0" y="0"/>
-            <a:ext cx="109728" cy="5143500"/>
-          </a:xfrm>
-          <a:prstGeom prst="rect">
-            <a:avLst/>
-          </a:prstGeom>
-          <a:solidFill>
-            <a:srgbClr val="2E75B6"/>
-          </a:solidFill>
-          <a:ln w="12700">
-            <a:solidFill>
-              <a:srgbClr val="2E75B6"/>
-            </a:solidFill>
-            <a:prstDash val="solid"/>
-          </a:ln>
-        </p:spPr>
-      </p:sp>
-      <p:sp>
-        <p:nvSpPr>
-          <p:cNvPr id="3" name="Text 1"/>
-          <p:cNvSpPr/>
-          <p:nvPr/>
-        </p:nvSpPr>
-        <p:spPr>
-          <a:xfrm>
-            <a:off x="274320" y="256032"/>
-            <a:ext cx="8595360" cy="502920"/>
-          </a:xfrm>
-          <a:prstGeom prst="rect">
-            <a:avLst/>
-          </a:prstGeom>
-          <a:noFill/>
-          <a:ln/>
-        </p:spPr>
-        <p:txBody>
-          <a:bodyPr wrap="square" lIns="0" tIns="0" rIns="0" bIns="0" rtlCol="0" anchor="ctr"/>
-          <a:lstStyle/>
-          <a:p>
-            <a:pPr indent="0" marL="0">
-              <a:buNone/>
-            </a:pPr>
-            <a:r>
-              <a:rPr lang="en-US" sz="2600" b="1" dirty="0">
-                <a:solidFill>
-                  <a:srgbClr val="1F3864"/>
-                </a:solidFill>
-                <a:latin typeface="Calibri" pitchFamily="34" charset="0"/>
-                <a:ea typeface="Calibri" pitchFamily="34" charset="-122"/>
-                <a:cs typeface="Calibri" pitchFamily="34" charset="-120"/>
-              </a:rPr>
-              <a:t>Three academic contributions</a:t>
-            </a:r>
-            <a:endParaRPr lang="en-US" sz="2600" dirty="0"/>
-          </a:p>
-        </p:txBody>
-      </p:sp>
-      <p:sp>
-        <p:nvSpPr>
-          <p:cNvPr id="4" name="Text 2"/>
-          <p:cNvSpPr/>
-          <p:nvPr/>
-        </p:nvSpPr>
-        <p:spPr>
-          <a:xfrm>
-            <a:off x="274320" y="749808"/>
-            <a:ext cx="8595360" cy="292608"/>
-          </a:xfrm>
-          <a:prstGeom prst="rect">
-            <a:avLst/>
-          </a:prstGeom>
-          <a:noFill/>
-          <a:ln/>
-        </p:spPr>
-        <p:txBody>
-          <a:bodyPr wrap="square" lIns="0" tIns="0" rIns="0" bIns="0" rtlCol="0" anchor="ctr"/>
-          <a:lstStyle/>
-          <a:p>
-            <a:pPr indent="0" marL="0">
-              <a:buNone/>
-            </a:pPr>
-            <a:r>
-              <a:rPr lang="en-US" sz="1300" dirty="0">
-                <a:solidFill>
-                  <a:srgbClr val="8896A6"/>
-                </a:solidFill>
-                <a:latin typeface="Calibri" pitchFamily="34" charset="0"/>
-                <a:ea typeface="Calibri" pitchFamily="34" charset="-122"/>
-                <a:cs typeface="Calibri" pitchFamily="34" charset="-120"/>
-              </a:rPr>
-              <a:t>What BIMGUARD AI adds to the body of knowledge</a:t>
-            </a:r>
-            <a:endParaRPr lang="en-US" sz="1300" dirty="0"/>
-          </a:p>
-        </p:txBody>
-      </p:sp>
-      <p:sp>
-        <p:nvSpPr>
-          <p:cNvPr id="5" name="Shape 3"/>
-          <p:cNvSpPr/>
-          <p:nvPr/>
-        </p:nvSpPr>
-        <p:spPr>
-          <a:xfrm>
-            <a:off x="274320" y="1078992"/>
-            <a:ext cx="8595360" cy="20117"/>
-          </a:xfrm>
-          <a:prstGeom prst="rect">
-            <a:avLst/>
-          </a:prstGeom>
-          <a:solidFill>
-            <a:srgbClr val="DEEAF1"/>
-          </a:solidFill>
-          <a:ln w="12700">
-            <a:solidFill>
-              <a:srgbClr val="DEEAF1"/>
-            </a:solidFill>
-            <a:prstDash val="solid"/>
-          </a:ln>
-        </p:spPr>
-      </p:sp>
-      <p:sp>
-        <p:nvSpPr>
-          <p:cNvPr id="6" name="Shape 4"/>
-          <p:cNvSpPr/>
-          <p:nvPr/>
-        </p:nvSpPr>
-        <p:spPr>
-          <a:xfrm>
-            <a:off x="228600" y="1234440"/>
-            <a:ext cx="8686800" cy="1005840"/>
-          </a:xfrm>
-          <a:prstGeom prst="rect">
-            <a:avLst/>
-          </a:prstGeom>
-          <a:solidFill>
-            <a:srgbClr val="FFFFFF"/>
-          </a:solidFill>
-          <a:ln w="12700">
-            <a:solidFill>
-              <a:srgbClr val="DEEAF1"/>
-            </a:solidFill>
-            <a:prstDash val="solid"/>
-          </a:ln>
-          <a:effectLst>
-            <a:outerShdw sx="100000" sy="100000" kx="0" ky="0" algn="bl" rotWithShape="0" blurRad="101600" dist="38100" dir="8100000">
-              <a:srgbClr val="000000">
-                <a:alpha val="12000"/>
-              </a:srgbClr>
-            </a:outerShdw>
-          </a:effectLst>
-        </p:spPr>
-      </p:sp>
-      <p:sp>
-        <p:nvSpPr>
-          <p:cNvPr id="7" name="Shape 5"/>
-          <p:cNvSpPr/>
-          <p:nvPr/>
-        </p:nvSpPr>
-        <p:spPr>
-          <a:xfrm>
-            <a:off x="228600" y="1234440"/>
-            <a:ext cx="64008" cy="1005840"/>
-          </a:xfrm>
-          <a:prstGeom prst="rect">
-            <a:avLst/>
-          </a:prstGeom>
-          <a:solidFill>
-            <a:srgbClr val="00B4D8"/>
-          </a:solidFill>
-          <a:ln w="12700">
-            <a:solidFill>
-              <a:srgbClr val="00B4D8"/>
-            </a:solidFill>
-            <a:prstDash val="solid"/>
-          </a:ln>
-        </p:spPr>
-      </p:sp>
-      <p:sp>
-        <p:nvSpPr>
-          <p:cNvPr id="8" name="Text 6"/>
-          <p:cNvSpPr/>
-          <p:nvPr/>
-        </p:nvSpPr>
-        <p:spPr>
-          <a:xfrm>
-            <a:off x="356616" y="1325880"/>
-            <a:ext cx="8485632" cy="292608"/>
-          </a:xfrm>
-          <a:prstGeom prst="rect">
-            <a:avLst/>
-          </a:prstGeom>
-          <a:noFill/>
-          <a:ln/>
-        </p:spPr>
-        <p:txBody>
-          <a:bodyPr wrap="square" lIns="0" tIns="0" rIns="0" bIns="0" rtlCol="0" anchor="ctr"/>
-          <a:lstStyle/>
-          <a:p>
-            <a:pPr indent="0" marL="0">
-              <a:buNone/>
-            </a:pPr>
-            <a:r>
-              <a:rPr lang="en-US" sz="1300" b="1" dirty="0">
-                <a:solidFill>
-                  <a:srgbClr val="1F3864"/>
-                </a:solidFill>
-                <a:latin typeface="Calibri" pitchFamily="34" charset="0"/>
-                <a:ea typeface="Calibri" pitchFamily="34" charset="-122"/>
-                <a:cs typeface="Calibri" pitchFamily="34" charset="-120"/>
-              </a:rPr>
-              <a:t>1  —  Corrosion compliance from IFC metadata without geometric modelling</a:t>
-            </a:r>
-            <a:endParaRPr lang="en-US" sz="1300" dirty="0"/>
-          </a:p>
-        </p:txBody>
-      </p:sp>
-      <p:sp>
-        <p:nvSpPr>
-          <p:cNvPr id="9" name="Text 7"/>
-          <p:cNvSpPr/>
-          <p:nvPr/>
-        </p:nvSpPr>
-        <p:spPr>
-          <a:xfrm>
-            <a:off x="356616" y="1618488"/>
-            <a:ext cx="8485632" cy="512064"/>
-          </a:xfrm>
-          <a:prstGeom prst="rect">
-            <a:avLst/>
-          </a:prstGeom>
-          <a:noFill/>
-          <a:ln/>
-        </p:spPr>
-        <p:txBody>
-          <a:bodyPr wrap="square" lIns="0" tIns="0" rIns="0" bIns="0" rtlCol="0" anchor="ctr"/>
-          <a:lstStyle/>
-          <a:p>
-            <a:pPr indent="0" marL="0">
-              <a:buNone/>
-            </a:pPr>
-            <a:r>
-              <a:rPr lang="en-US" sz="1100" dirty="0">
-                <a:solidFill>
-                  <a:srgbClr val="374151"/>
-                </a:solidFill>
-                <a:latin typeface="Calibri" pitchFamily="34" charset="0"/>
-                <a:ea typeface="Calibri" pitchFamily="34" charset="-122"/>
-                <a:cs typeface="Calibri" pitchFamily="34" charset="-120"/>
-              </a:rPr>
-              <a:t>Demonstrates that engineering-level corrosion risk assessment can be performed on property set metadata without requiring insulation, supports, or joint geometry to be modelled as 3D solids. Addresses a fundamental limitation of all current BIM clash detection tools.</a:t>
-            </a:r>
-            <a:endParaRPr lang="en-US" sz="1100" dirty="0"/>
-          </a:p>
-        </p:txBody>
-      </p:sp>
-      <p:sp>
-        <p:nvSpPr>
-          <p:cNvPr id="10" name="Shape 8"/>
-          <p:cNvSpPr/>
-          <p:nvPr/>
-        </p:nvSpPr>
-        <p:spPr>
-          <a:xfrm>
-            <a:off x="228600" y="2395728"/>
-            <a:ext cx="8686800" cy="1005840"/>
-          </a:xfrm>
-          <a:prstGeom prst="rect">
-            <a:avLst/>
-          </a:prstGeom>
-          <a:solidFill>
-            <a:srgbClr val="FFFFFF"/>
-          </a:solidFill>
-          <a:ln w="12700">
-            <a:solidFill>
-              <a:srgbClr val="DEEAF1"/>
-            </a:solidFill>
-            <a:prstDash val="solid"/>
-          </a:ln>
-          <a:effectLst>
-            <a:outerShdw sx="100000" sy="100000" kx="0" ky="0" algn="bl" rotWithShape="0" blurRad="101600" dist="38100" dir="8100000">
-              <a:srgbClr val="000000">
-                <a:alpha val="12000"/>
-              </a:srgbClr>
-            </a:outerShdw>
-          </a:effectLst>
-        </p:spPr>
-      </p:sp>
-      <p:sp>
-        <p:nvSpPr>
-          <p:cNvPr id="11" name="Shape 9"/>
-          <p:cNvSpPr/>
-          <p:nvPr/>
-        </p:nvSpPr>
-        <p:spPr>
-          <a:xfrm>
-            <a:off x="228600" y="2395728"/>
-            <a:ext cx="64008" cy="1005840"/>
-          </a:xfrm>
-          <a:prstGeom prst="rect">
-            <a:avLst/>
-          </a:prstGeom>
-          <a:solidFill>
-            <a:srgbClr val="2E75B6"/>
-          </a:solidFill>
-          <a:ln w="12700">
-            <a:solidFill>
-              <a:srgbClr val="2E75B6"/>
-            </a:solidFill>
-            <a:prstDash val="solid"/>
-          </a:ln>
-        </p:spPr>
-      </p:sp>
-      <p:sp>
-        <p:nvSpPr>
-          <p:cNvPr id="12" name="Text 10"/>
-          <p:cNvSpPr/>
-          <p:nvPr/>
-        </p:nvSpPr>
-        <p:spPr>
-          <a:xfrm>
-            <a:off x="356616" y="2487168"/>
-            <a:ext cx="8485632" cy="292608"/>
-          </a:xfrm>
-          <a:prstGeom prst="rect">
-            <a:avLst/>
-          </a:prstGeom>
-          <a:noFill/>
-          <a:ln/>
-        </p:spPr>
-        <p:txBody>
-          <a:bodyPr wrap="square" lIns="0" tIns="0" rIns="0" bIns="0" rtlCol="0" anchor="ctr"/>
-          <a:lstStyle/>
-          <a:p>
-            <a:pPr indent="0" marL="0">
-              <a:buNone/>
-            </a:pPr>
-            <a:r>
-              <a:rPr lang="en-US" sz="1300" b="1" dirty="0">
-                <a:solidFill>
-                  <a:srgbClr val="1F3864"/>
-                </a:solidFill>
-                <a:latin typeface="Calibri" pitchFamily="34" charset="0"/>
-                <a:ea typeface="Calibri" pitchFamily="34" charset="-122"/>
-                <a:cs typeface="Calibri" pitchFamily="34" charset="-120"/>
-              </a:rPr>
-              <a:t>2  —  White Box Architecture for AI-assisted compliance checking</a:t>
-            </a:r>
-            <a:endParaRPr lang="en-US" sz="1300" dirty="0"/>
-          </a:p>
-        </p:txBody>
-      </p:sp>
-      <p:sp>
-        <p:nvSpPr>
-          <p:cNvPr id="13" name="Text 11"/>
-          <p:cNvSpPr/>
-          <p:nvPr/>
-        </p:nvSpPr>
-        <p:spPr>
-          <a:xfrm>
-            <a:off x="356616" y="2779776"/>
-            <a:ext cx="8485632" cy="512064"/>
-          </a:xfrm>
-          <a:prstGeom prst="rect">
-            <a:avLst/>
-          </a:prstGeom>
-          <a:noFill/>
-          <a:ln/>
-        </p:spPr>
-        <p:txBody>
-          <a:bodyPr wrap="square" lIns="0" tIns="0" rIns="0" bIns="0" rtlCol="0" anchor="ctr"/>
-          <a:lstStyle/>
-          <a:p>
-            <a:pPr indent="0" marL="0">
-              <a:buNone/>
-            </a:pPr>
-            <a:r>
-              <a:rPr lang="en-US" sz="1100" dirty="0">
-                <a:solidFill>
-                  <a:srgbClr val="374151"/>
-                </a:solidFill>
-                <a:latin typeface="Calibri" pitchFamily="34" charset="0"/>
-                <a:ea typeface="Calibri" pitchFamily="34" charset="-122"/>
-                <a:cs typeface="Calibri" pitchFamily="34" charset="-120"/>
-              </a:rPr>
-              <a:t>Establishes a methodology in which every compliance decision is traceable to a named standard and a specific threshold. Demonstrates that transparent, auditable rule-based compliance checking is viable in a BIM context — and preferable to black-box ML approaches for regulatory acceptance.</a:t>
-            </a:r>
-            <a:endParaRPr lang="en-US" sz="1100" dirty="0"/>
-          </a:p>
-        </p:txBody>
-      </p:sp>
-      <p:sp>
-        <p:nvSpPr>
-          <p:cNvPr id="14" name="Shape 12"/>
-          <p:cNvSpPr/>
-          <p:nvPr/>
-        </p:nvSpPr>
-        <p:spPr>
-          <a:xfrm>
-            <a:off x="228600" y="3557016"/>
-            <a:ext cx="8686800" cy="1005840"/>
-          </a:xfrm>
-          <a:prstGeom prst="rect">
-            <a:avLst/>
-          </a:prstGeom>
-          <a:solidFill>
-            <a:srgbClr val="FFFFFF"/>
-          </a:solidFill>
-          <a:ln w="12700">
-            <a:solidFill>
-              <a:srgbClr val="DEEAF1"/>
-            </a:solidFill>
-            <a:prstDash val="solid"/>
-          </a:ln>
-          <a:effectLst>
-            <a:outerShdw sx="100000" sy="100000" kx="0" ky="0" algn="bl" rotWithShape="0" blurRad="101600" dist="38100" dir="8100000">
-              <a:srgbClr val="000000">
-                <a:alpha val="12000"/>
-              </a:srgbClr>
-            </a:outerShdw>
-          </a:effectLst>
-        </p:spPr>
-      </p:sp>
-      <p:sp>
-        <p:nvSpPr>
-          <p:cNvPr id="15" name="Shape 13"/>
-          <p:cNvSpPr/>
-          <p:nvPr/>
-        </p:nvSpPr>
-        <p:spPr>
-          <a:xfrm>
-            <a:off x="228600" y="3557016"/>
-            <a:ext cx="64008" cy="1005840"/>
-          </a:xfrm>
-          <a:prstGeom prst="rect">
-            <a:avLst/>
-          </a:prstGeom>
-          <a:solidFill>
-            <a:srgbClr val="1F3864"/>
-          </a:solidFill>
-          <a:ln w="12700">
-            <a:solidFill>
-              <a:srgbClr val="1F3864"/>
-            </a:solidFill>
-            <a:prstDash val="solid"/>
-          </a:ln>
-        </p:spPr>
-      </p:sp>
-      <p:sp>
-        <p:nvSpPr>
-          <p:cNvPr id="16" name="Text 14"/>
-          <p:cNvSpPr/>
-          <p:nvPr/>
-        </p:nvSpPr>
-        <p:spPr>
-          <a:xfrm>
-            <a:off x="356616" y="3648456"/>
-            <a:ext cx="8485632" cy="292608"/>
-          </a:xfrm>
-          <a:prstGeom prst="rect">
-            <a:avLst/>
-          </a:prstGeom>
-          <a:noFill/>
-          <a:ln/>
-        </p:spPr>
-        <p:txBody>
-          <a:bodyPr wrap="square" lIns="0" tIns="0" rIns="0" bIns="0" rtlCol="0" anchor="ctr"/>
-          <a:lstStyle/>
-          <a:p>
-            <a:pPr indent="0" marL="0">
-              <a:buNone/>
-            </a:pPr>
-            <a:r>
-              <a:rPr lang="en-US" sz="1300" b="1" dirty="0">
-                <a:solidFill>
-                  <a:srgbClr val="1F3864"/>
-                </a:solidFill>
-                <a:latin typeface="Calibri" pitchFamily="34" charset="0"/>
-                <a:ea typeface="Calibri" pitchFamily="34" charset="-122"/>
-                <a:cs typeface="Calibri" pitchFamily="34" charset="-120"/>
-              </a:rPr>
-              <a:t>3  —  Halo Envelope: proactive LOD 350 space reservation at LOD 300</a:t>
-            </a:r>
-            <a:endParaRPr lang="en-US" sz="1300" dirty="0"/>
-          </a:p>
-        </p:txBody>
-      </p:sp>
-      <p:sp>
-        <p:nvSpPr>
-          <p:cNvPr id="17" name="Text 15"/>
-          <p:cNvSpPr/>
-          <p:nvPr/>
-        </p:nvSpPr>
-        <p:spPr>
-          <a:xfrm>
-            <a:off x="356616" y="3941064"/>
-            <a:ext cx="8485632" cy="512064"/>
-          </a:xfrm>
-          <a:prstGeom prst="rect">
-            <a:avLst/>
-          </a:prstGeom>
-          <a:noFill/>
-          <a:ln/>
-        </p:spPr>
-        <p:txBody>
-          <a:bodyPr wrap="square" lIns="0" tIns="0" rIns="0" bIns="0" rtlCol="0" anchor="ctr"/>
-          <a:lstStyle/>
-          <a:p>
-            <a:pPr indent="0" marL="0">
-              <a:buNone/>
-            </a:pPr>
-            <a:r>
-              <a:rPr lang="en-US" sz="1100" dirty="0">
-                <a:solidFill>
-                  <a:srgbClr val="374151"/>
-                </a:solidFill>
-                <a:latin typeface="Calibri" pitchFamily="34" charset="0"/>
-                <a:ea typeface="Calibri" pitchFamily="34" charset="-122"/>
-                <a:cs typeface="Calibri" pitchFamily="34" charset="-120"/>
-              </a:rPr>
-              <a:t>Introduces a formal method for reserving space for LOD 350 support steelwork within a LOD 300 coordination model. Addresses a recognised and costly gap in current BIM coordination practice — the 'Coordination Fatigue' problem where 80% of meeting time is spent deciding who moves.</a:t>
-            </a:r>
-            <a:endParaRPr lang="en-US" sz="1100" dirty="0"/>
-          </a:p>
-        </p:txBody>
-      </p:sp>
-      <p:sp>
-        <p:nvSpPr>
-          <p:cNvPr id="18" name="Shape 16"/>
-          <p:cNvSpPr/>
-          <p:nvPr/>
-        </p:nvSpPr>
-        <p:spPr>
-          <a:xfrm>
-            <a:off x="0" y="4892040"/>
-            <a:ext cx="9144000" cy="251460"/>
-          </a:xfrm>
-          <a:prstGeom prst="rect">
-            <a:avLst/>
-          </a:prstGeom>
-          <a:solidFill>
-            <a:srgbClr val="1F3864"/>
-          </a:solidFill>
-          <a:ln w="12700">
-            <a:solidFill>
-              <a:srgbClr val="1F3864"/>
-            </a:solidFill>
-            <a:prstDash val="solid"/>
-          </a:ln>
-        </p:spPr>
-      </p:sp>
-      <p:sp>
-        <p:nvSpPr>
-          <p:cNvPr id="19" name="Text 17"/>
-          <p:cNvSpPr/>
-          <p:nvPr/>
-        </p:nvSpPr>
-        <p:spPr>
-          <a:xfrm>
-            <a:off x="228600" y="4901184"/>
-            <a:ext cx="8686800" cy="228600"/>
-          </a:xfrm>
-          <a:prstGeom prst="rect">
-            <a:avLst/>
-          </a:prstGeom>
-          <a:noFill/>
-          <a:ln/>
-        </p:spPr>
-        <p:txBody>
-          <a:bodyPr wrap="square" lIns="0" tIns="0" rIns="0" bIns="0" rtlCol="0" anchor="ctr"/>
-          <a:lstStyle/>
-          <a:p>
-            <a:pPr indent="0" marL="0">
-              <a:buNone/>
-            </a:pPr>
-            <a:r>
-              <a:rPr lang="en-US" sz="850" dirty="0">
-                <a:solidFill>
-                  <a:srgbClr val="FFFFFF"/>
                 </a:solidFill>
                 <a:latin typeface="Calibri" pitchFamily="34" charset="0"/>
                 <a:ea typeface="Calibri" pitchFamily="34" charset="-122"/>
@@ -12944,6 +13276,635 @@
 
 <file path=ppt/slides/slide20.xml><?xml version="1.0" encoding="utf-8"?>
 <p:sld xmlns:a="http://schemas.openxmlformats.org/drawingml/2006/main" xmlns:r="http://schemas.openxmlformats.org/officeDocument/2006/relationships" xmlns:p="http://schemas.openxmlformats.org/presentationml/2006/main">
+  <p:cSld name="Slide 19">
+    <p:bg>
+      <p:bgPr>
+        <a:solidFill>
+          <a:srgbClr val="F4F6FB"/>
+        </a:solidFill>
+      </p:bgPr>
+    </p:bg>
+    <p:spTree>
+      <p:nvGrpSpPr>
+        <p:cNvPr id="1" name=""/>
+        <p:cNvGrpSpPr/>
+        <p:nvPr/>
+      </p:nvGrpSpPr>
+      <p:grpSpPr>
+        <a:xfrm>
+          <a:off x="0" y="0"/>
+          <a:ext cx="0" cy="0"/>
+          <a:chOff x="0" y="0"/>
+          <a:chExt cx="0" cy="0"/>
+        </a:xfrm>
+      </p:grpSpPr>
+      <p:sp>
+        <p:nvSpPr>
+          <p:cNvPr id="2" name="Shape 0"/>
+          <p:cNvSpPr/>
+          <p:nvPr/>
+        </p:nvSpPr>
+        <p:spPr>
+          <a:xfrm>
+            <a:off x="0" y="0"/>
+            <a:ext cx="109728" cy="5143500"/>
+          </a:xfrm>
+          <a:prstGeom prst="rect">
+            <a:avLst/>
+          </a:prstGeom>
+          <a:solidFill>
+            <a:srgbClr val="2E75B6"/>
+          </a:solidFill>
+          <a:ln w="12700">
+            <a:solidFill>
+              <a:srgbClr val="2E75B6"/>
+            </a:solidFill>
+            <a:prstDash val="solid"/>
+          </a:ln>
+        </p:spPr>
+      </p:sp>
+      <p:sp>
+        <p:nvSpPr>
+          <p:cNvPr id="3" name="Text 1"/>
+          <p:cNvSpPr/>
+          <p:nvPr/>
+        </p:nvSpPr>
+        <p:spPr>
+          <a:xfrm>
+            <a:off x="274320" y="256032"/>
+            <a:ext cx="8595360" cy="502920"/>
+          </a:xfrm>
+          <a:prstGeom prst="rect">
+            <a:avLst/>
+          </a:prstGeom>
+          <a:noFill/>
+          <a:ln/>
+        </p:spPr>
+        <p:txBody>
+          <a:bodyPr wrap="square" lIns="0" tIns="0" rIns="0" bIns="0" rtlCol="0" anchor="ctr"/>
+          <a:lstStyle/>
+          <a:p>
+            <a:pPr indent="0" marL="0">
+              <a:buNone/>
+            </a:pPr>
+            <a:r>
+              <a:rPr lang="en-US" sz="2600" b="1" dirty="0">
+                <a:solidFill>
+                  <a:srgbClr val="1F3864"/>
+                </a:solidFill>
+                <a:latin typeface="Calibri" pitchFamily="34" charset="0"/>
+                <a:ea typeface="Calibri" pitchFamily="34" charset="-122"/>
+                <a:cs typeface="Calibri" pitchFamily="34" charset="-120"/>
+              </a:rPr>
+              <a:t>Three academic contributions</a:t>
+            </a:r>
+            <a:endParaRPr lang="en-US" sz="2600" dirty="0"/>
+          </a:p>
+        </p:txBody>
+      </p:sp>
+      <p:sp>
+        <p:nvSpPr>
+          <p:cNvPr id="4" name="Text 2"/>
+          <p:cNvSpPr/>
+          <p:nvPr/>
+        </p:nvSpPr>
+        <p:spPr>
+          <a:xfrm>
+            <a:off x="274320" y="749808"/>
+            <a:ext cx="8595360" cy="292608"/>
+          </a:xfrm>
+          <a:prstGeom prst="rect">
+            <a:avLst/>
+          </a:prstGeom>
+          <a:noFill/>
+          <a:ln/>
+        </p:spPr>
+        <p:txBody>
+          <a:bodyPr wrap="square" lIns="0" tIns="0" rIns="0" bIns="0" rtlCol="0" anchor="ctr"/>
+          <a:lstStyle/>
+          <a:p>
+            <a:pPr indent="0" marL="0">
+              <a:buNone/>
+            </a:pPr>
+            <a:r>
+              <a:rPr lang="en-US" sz="1300" dirty="0">
+                <a:solidFill>
+                  <a:srgbClr val="8896A6"/>
+                </a:solidFill>
+                <a:latin typeface="Calibri" pitchFamily="34" charset="0"/>
+                <a:ea typeface="Calibri" pitchFamily="34" charset="-122"/>
+                <a:cs typeface="Calibri" pitchFamily="34" charset="-120"/>
+              </a:rPr>
+              <a:t>What BIMGUARD AI adds to the body of knowledge</a:t>
+            </a:r>
+            <a:endParaRPr lang="en-US" sz="1300" dirty="0"/>
+          </a:p>
+        </p:txBody>
+      </p:sp>
+      <p:sp>
+        <p:nvSpPr>
+          <p:cNvPr id="5" name="Shape 3"/>
+          <p:cNvSpPr/>
+          <p:nvPr/>
+        </p:nvSpPr>
+        <p:spPr>
+          <a:xfrm>
+            <a:off x="274320" y="1078992"/>
+            <a:ext cx="8595360" cy="20117"/>
+          </a:xfrm>
+          <a:prstGeom prst="rect">
+            <a:avLst/>
+          </a:prstGeom>
+          <a:solidFill>
+            <a:srgbClr val="DEEAF1"/>
+          </a:solidFill>
+          <a:ln w="12700">
+            <a:solidFill>
+              <a:srgbClr val="DEEAF1"/>
+            </a:solidFill>
+            <a:prstDash val="solid"/>
+          </a:ln>
+        </p:spPr>
+      </p:sp>
+      <p:sp>
+        <p:nvSpPr>
+          <p:cNvPr id="6" name="Shape 4"/>
+          <p:cNvSpPr/>
+          <p:nvPr/>
+        </p:nvSpPr>
+        <p:spPr>
+          <a:xfrm>
+            <a:off x="228600" y="1234440"/>
+            <a:ext cx="8686800" cy="1005840"/>
+          </a:xfrm>
+          <a:prstGeom prst="rect">
+            <a:avLst/>
+          </a:prstGeom>
+          <a:solidFill>
+            <a:srgbClr val="FFFFFF"/>
+          </a:solidFill>
+          <a:ln w="12700">
+            <a:solidFill>
+              <a:srgbClr val="DEEAF1"/>
+            </a:solidFill>
+            <a:prstDash val="solid"/>
+          </a:ln>
+          <a:effectLst>
+            <a:outerShdw sx="100000" sy="100000" kx="0" ky="0" algn="bl" rotWithShape="0" blurRad="101600" dist="38100" dir="8100000">
+              <a:srgbClr val="000000">
+                <a:alpha val="12000"/>
+              </a:srgbClr>
+            </a:outerShdw>
+          </a:effectLst>
+        </p:spPr>
+      </p:sp>
+      <p:sp>
+        <p:nvSpPr>
+          <p:cNvPr id="7" name="Shape 5"/>
+          <p:cNvSpPr/>
+          <p:nvPr/>
+        </p:nvSpPr>
+        <p:spPr>
+          <a:xfrm>
+            <a:off x="228600" y="1234440"/>
+            <a:ext cx="64008" cy="1005840"/>
+          </a:xfrm>
+          <a:prstGeom prst="rect">
+            <a:avLst/>
+          </a:prstGeom>
+          <a:solidFill>
+            <a:srgbClr val="00B4D8"/>
+          </a:solidFill>
+          <a:ln w="12700">
+            <a:solidFill>
+              <a:srgbClr val="00B4D8"/>
+            </a:solidFill>
+            <a:prstDash val="solid"/>
+          </a:ln>
+        </p:spPr>
+      </p:sp>
+      <p:sp>
+        <p:nvSpPr>
+          <p:cNvPr id="8" name="Text 6"/>
+          <p:cNvSpPr/>
+          <p:nvPr/>
+        </p:nvSpPr>
+        <p:spPr>
+          <a:xfrm>
+            <a:off x="356616" y="1325880"/>
+            <a:ext cx="8485632" cy="292608"/>
+          </a:xfrm>
+          <a:prstGeom prst="rect">
+            <a:avLst/>
+          </a:prstGeom>
+          <a:noFill/>
+          <a:ln/>
+        </p:spPr>
+        <p:txBody>
+          <a:bodyPr wrap="square" lIns="0" tIns="0" rIns="0" bIns="0" rtlCol="0" anchor="ctr"/>
+          <a:lstStyle/>
+          <a:p>
+            <a:pPr indent="0" marL="0">
+              <a:buNone/>
+            </a:pPr>
+            <a:r>
+              <a:rPr lang="en-US" sz="1300" b="1" dirty="0">
+                <a:solidFill>
+                  <a:srgbClr val="1F3864"/>
+                </a:solidFill>
+                <a:latin typeface="Calibri" pitchFamily="34" charset="0"/>
+                <a:ea typeface="Calibri" pitchFamily="34" charset="-122"/>
+                <a:cs typeface="Calibri" pitchFamily="34" charset="-120"/>
+              </a:rPr>
+              <a:t>1  —  Corrosion compliance from IFC metadata without geometric modelling</a:t>
+            </a:r>
+            <a:endParaRPr lang="en-US" sz="1300" dirty="0"/>
+          </a:p>
+        </p:txBody>
+      </p:sp>
+      <p:sp>
+        <p:nvSpPr>
+          <p:cNvPr id="9" name="Text 7"/>
+          <p:cNvSpPr/>
+          <p:nvPr/>
+        </p:nvSpPr>
+        <p:spPr>
+          <a:xfrm>
+            <a:off x="356616" y="1618488"/>
+            <a:ext cx="8485632" cy="512064"/>
+          </a:xfrm>
+          <a:prstGeom prst="rect">
+            <a:avLst/>
+          </a:prstGeom>
+          <a:noFill/>
+          <a:ln/>
+        </p:spPr>
+        <p:txBody>
+          <a:bodyPr wrap="square" lIns="0" tIns="0" rIns="0" bIns="0" rtlCol="0" anchor="ctr"/>
+          <a:lstStyle/>
+          <a:p>
+            <a:pPr indent="0" marL="0">
+              <a:buNone/>
+            </a:pPr>
+            <a:r>
+              <a:rPr lang="en-US" sz="1100" dirty="0">
+                <a:solidFill>
+                  <a:srgbClr val="374151"/>
+                </a:solidFill>
+                <a:latin typeface="Calibri" pitchFamily="34" charset="0"/>
+                <a:ea typeface="Calibri" pitchFamily="34" charset="-122"/>
+                <a:cs typeface="Calibri" pitchFamily="34" charset="-120"/>
+              </a:rPr>
+              <a:t>Demonstrates that engineering-level corrosion risk assessment can be performed on property set metadata without requiring insulation, supports, or joint geometry to be modelled as 3D solids. Addresses a fundamental limitation of all current BIM clash detection tools.</a:t>
+            </a:r>
+            <a:endParaRPr lang="en-US" sz="1100" dirty="0"/>
+          </a:p>
+        </p:txBody>
+      </p:sp>
+      <p:sp>
+        <p:nvSpPr>
+          <p:cNvPr id="10" name="Shape 8"/>
+          <p:cNvSpPr/>
+          <p:nvPr/>
+        </p:nvSpPr>
+        <p:spPr>
+          <a:xfrm>
+            <a:off x="228600" y="2395728"/>
+            <a:ext cx="8686800" cy="1005840"/>
+          </a:xfrm>
+          <a:prstGeom prst="rect">
+            <a:avLst/>
+          </a:prstGeom>
+          <a:solidFill>
+            <a:srgbClr val="FFFFFF"/>
+          </a:solidFill>
+          <a:ln w="12700">
+            <a:solidFill>
+              <a:srgbClr val="DEEAF1"/>
+            </a:solidFill>
+            <a:prstDash val="solid"/>
+          </a:ln>
+          <a:effectLst>
+            <a:outerShdw sx="100000" sy="100000" kx="0" ky="0" algn="bl" rotWithShape="0" blurRad="101600" dist="38100" dir="8100000">
+              <a:srgbClr val="000000">
+                <a:alpha val="12000"/>
+              </a:srgbClr>
+            </a:outerShdw>
+          </a:effectLst>
+        </p:spPr>
+      </p:sp>
+      <p:sp>
+        <p:nvSpPr>
+          <p:cNvPr id="11" name="Shape 9"/>
+          <p:cNvSpPr/>
+          <p:nvPr/>
+        </p:nvSpPr>
+        <p:spPr>
+          <a:xfrm>
+            <a:off x="228600" y="2395728"/>
+            <a:ext cx="64008" cy="1005840"/>
+          </a:xfrm>
+          <a:prstGeom prst="rect">
+            <a:avLst/>
+          </a:prstGeom>
+          <a:solidFill>
+            <a:srgbClr val="2E75B6"/>
+          </a:solidFill>
+          <a:ln w="12700">
+            <a:solidFill>
+              <a:srgbClr val="2E75B6"/>
+            </a:solidFill>
+            <a:prstDash val="solid"/>
+          </a:ln>
+        </p:spPr>
+      </p:sp>
+      <p:sp>
+        <p:nvSpPr>
+          <p:cNvPr id="12" name="Text 10"/>
+          <p:cNvSpPr/>
+          <p:nvPr/>
+        </p:nvSpPr>
+        <p:spPr>
+          <a:xfrm>
+            <a:off x="356616" y="2487168"/>
+            <a:ext cx="8485632" cy="292608"/>
+          </a:xfrm>
+          <a:prstGeom prst="rect">
+            <a:avLst/>
+          </a:prstGeom>
+          <a:noFill/>
+          <a:ln/>
+        </p:spPr>
+        <p:txBody>
+          <a:bodyPr wrap="square" lIns="0" tIns="0" rIns="0" bIns="0" rtlCol="0" anchor="ctr"/>
+          <a:lstStyle/>
+          <a:p>
+            <a:pPr indent="0" marL="0">
+              <a:buNone/>
+            </a:pPr>
+            <a:r>
+              <a:rPr lang="en-US" sz="1300" b="1" dirty="0">
+                <a:solidFill>
+                  <a:srgbClr val="1F3864"/>
+                </a:solidFill>
+                <a:latin typeface="Calibri" pitchFamily="34" charset="0"/>
+                <a:ea typeface="Calibri" pitchFamily="34" charset="-122"/>
+                <a:cs typeface="Calibri" pitchFamily="34" charset="-120"/>
+              </a:rPr>
+              <a:t>2  —  White Box Architecture for AI-assisted compliance checking</a:t>
+            </a:r>
+            <a:endParaRPr lang="en-US" sz="1300" dirty="0"/>
+          </a:p>
+        </p:txBody>
+      </p:sp>
+      <p:sp>
+        <p:nvSpPr>
+          <p:cNvPr id="13" name="Text 11"/>
+          <p:cNvSpPr/>
+          <p:nvPr/>
+        </p:nvSpPr>
+        <p:spPr>
+          <a:xfrm>
+            <a:off x="356616" y="2779776"/>
+            <a:ext cx="8485632" cy="512064"/>
+          </a:xfrm>
+          <a:prstGeom prst="rect">
+            <a:avLst/>
+          </a:prstGeom>
+          <a:noFill/>
+          <a:ln/>
+        </p:spPr>
+        <p:txBody>
+          <a:bodyPr wrap="square" lIns="0" tIns="0" rIns="0" bIns="0" rtlCol="0" anchor="ctr"/>
+          <a:lstStyle/>
+          <a:p>
+            <a:pPr indent="0" marL="0">
+              <a:buNone/>
+            </a:pPr>
+            <a:r>
+              <a:rPr lang="en-US" sz="1100" dirty="0">
+                <a:solidFill>
+                  <a:srgbClr val="374151"/>
+                </a:solidFill>
+                <a:latin typeface="Calibri" pitchFamily="34" charset="0"/>
+                <a:ea typeface="Calibri" pitchFamily="34" charset="-122"/>
+                <a:cs typeface="Calibri" pitchFamily="34" charset="-120"/>
+              </a:rPr>
+              <a:t>Establishes a methodology in which every compliance decision is traceable to a named standard and a specific threshold. Demonstrates that transparent, auditable rule-based compliance checking is viable in a BIM context — and preferable to black-box ML approaches for regulatory acceptance.</a:t>
+            </a:r>
+            <a:endParaRPr lang="en-US" sz="1100" dirty="0"/>
+          </a:p>
+        </p:txBody>
+      </p:sp>
+      <p:sp>
+        <p:nvSpPr>
+          <p:cNvPr id="14" name="Shape 12"/>
+          <p:cNvSpPr/>
+          <p:nvPr/>
+        </p:nvSpPr>
+        <p:spPr>
+          <a:xfrm>
+            <a:off x="228600" y="3557016"/>
+            <a:ext cx="8686800" cy="1005840"/>
+          </a:xfrm>
+          <a:prstGeom prst="rect">
+            <a:avLst/>
+          </a:prstGeom>
+          <a:solidFill>
+            <a:srgbClr val="FFFFFF"/>
+          </a:solidFill>
+          <a:ln w="12700">
+            <a:solidFill>
+              <a:srgbClr val="DEEAF1"/>
+            </a:solidFill>
+            <a:prstDash val="solid"/>
+          </a:ln>
+          <a:effectLst>
+            <a:outerShdw sx="100000" sy="100000" kx="0" ky="0" algn="bl" rotWithShape="0" blurRad="101600" dist="38100" dir="8100000">
+              <a:srgbClr val="000000">
+                <a:alpha val="12000"/>
+              </a:srgbClr>
+            </a:outerShdw>
+          </a:effectLst>
+        </p:spPr>
+      </p:sp>
+      <p:sp>
+        <p:nvSpPr>
+          <p:cNvPr id="15" name="Shape 13"/>
+          <p:cNvSpPr/>
+          <p:nvPr/>
+        </p:nvSpPr>
+        <p:spPr>
+          <a:xfrm>
+            <a:off x="228600" y="3557016"/>
+            <a:ext cx="64008" cy="1005840"/>
+          </a:xfrm>
+          <a:prstGeom prst="rect">
+            <a:avLst/>
+          </a:prstGeom>
+          <a:solidFill>
+            <a:srgbClr val="1F3864"/>
+          </a:solidFill>
+          <a:ln w="12700">
+            <a:solidFill>
+              <a:srgbClr val="1F3864"/>
+            </a:solidFill>
+            <a:prstDash val="solid"/>
+          </a:ln>
+        </p:spPr>
+      </p:sp>
+      <p:sp>
+        <p:nvSpPr>
+          <p:cNvPr id="16" name="Text 14"/>
+          <p:cNvSpPr/>
+          <p:nvPr/>
+        </p:nvSpPr>
+        <p:spPr>
+          <a:xfrm>
+            <a:off x="356616" y="3648456"/>
+            <a:ext cx="8485632" cy="292608"/>
+          </a:xfrm>
+          <a:prstGeom prst="rect">
+            <a:avLst/>
+          </a:prstGeom>
+          <a:noFill/>
+          <a:ln/>
+        </p:spPr>
+        <p:txBody>
+          <a:bodyPr wrap="square" lIns="0" tIns="0" rIns="0" bIns="0" rtlCol="0" anchor="ctr"/>
+          <a:lstStyle/>
+          <a:p>
+            <a:pPr indent="0" marL="0">
+              <a:buNone/>
+            </a:pPr>
+            <a:r>
+              <a:rPr lang="en-US" sz="1300" b="1" dirty="0">
+                <a:solidFill>
+                  <a:srgbClr val="1F3864"/>
+                </a:solidFill>
+                <a:latin typeface="Calibri" pitchFamily="34" charset="0"/>
+                <a:ea typeface="Calibri" pitchFamily="34" charset="-122"/>
+                <a:cs typeface="Calibri" pitchFamily="34" charset="-120"/>
+              </a:rPr>
+              <a:t>3  —  Halo Envelope: proactive LOD 350 space reservation at LOD 300</a:t>
+            </a:r>
+            <a:endParaRPr lang="en-US" sz="1300" dirty="0"/>
+          </a:p>
+        </p:txBody>
+      </p:sp>
+      <p:sp>
+        <p:nvSpPr>
+          <p:cNvPr id="17" name="Text 15"/>
+          <p:cNvSpPr/>
+          <p:nvPr/>
+        </p:nvSpPr>
+        <p:spPr>
+          <a:xfrm>
+            <a:off x="356616" y="3941064"/>
+            <a:ext cx="8485632" cy="512064"/>
+          </a:xfrm>
+          <a:prstGeom prst="rect">
+            <a:avLst/>
+          </a:prstGeom>
+          <a:noFill/>
+          <a:ln/>
+        </p:spPr>
+        <p:txBody>
+          <a:bodyPr wrap="square" lIns="0" tIns="0" rIns="0" bIns="0" rtlCol="0" anchor="ctr"/>
+          <a:lstStyle/>
+          <a:p>
+            <a:pPr indent="0" marL="0">
+              <a:buNone/>
+            </a:pPr>
+            <a:r>
+              <a:rPr lang="en-US" sz="1100" dirty="0">
+                <a:solidFill>
+                  <a:srgbClr val="374151"/>
+                </a:solidFill>
+                <a:latin typeface="Calibri" pitchFamily="34" charset="0"/>
+                <a:ea typeface="Calibri" pitchFamily="34" charset="-122"/>
+                <a:cs typeface="Calibri" pitchFamily="34" charset="-120"/>
+              </a:rPr>
+              <a:t>Introduces a formal method for reserving space for LOD 350 support steelwork within a LOD 300 coordination model. Addresses a recognised and costly gap in current BIM coordination practice — the 'Coordination Fatigue' problem where 80% of meeting time is spent deciding who moves.</a:t>
+            </a:r>
+            <a:endParaRPr lang="en-US" sz="1100" dirty="0"/>
+          </a:p>
+        </p:txBody>
+      </p:sp>
+      <p:sp>
+        <p:nvSpPr>
+          <p:cNvPr id="18" name="Shape 16"/>
+          <p:cNvSpPr/>
+          <p:nvPr/>
+        </p:nvSpPr>
+        <p:spPr>
+          <a:xfrm>
+            <a:off x="0" y="4892040"/>
+            <a:ext cx="9144000" cy="251460"/>
+          </a:xfrm>
+          <a:prstGeom prst="rect">
+            <a:avLst/>
+          </a:prstGeom>
+          <a:solidFill>
+            <a:srgbClr val="1F3864"/>
+          </a:solidFill>
+          <a:ln w="12700">
+            <a:solidFill>
+              <a:srgbClr val="1F3864"/>
+            </a:solidFill>
+            <a:prstDash val="solid"/>
+          </a:ln>
+        </p:spPr>
+      </p:sp>
+      <p:sp>
+        <p:nvSpPr>
+          <p:cNvPr id="19" name="Text 17"/>
+          <p:cNvSpPr/>
+          <p:nvPr/>
+        </p:nvSpPr>
+        <p:spPr>
+          <a:xfrm>
+            <a:off x="228600" y="4901184"/>
+            <a:ext cx="8686800" cy="228600"/>
+          </a:xfrm>
+          <a:prstGeom prst="rect">
+            <a:avLst/>
+          </a:prstGeom>
+          <a:noFill/>
+          <a:ln/>
+        </p:spPr>
+        <p:txBody>
+          <a:bodyPr wrap="square" lIns="0" tIns="0" rIns="0" bIns="0" rtlCol="0" anchor="ctr"/>
+          <a:lstStyle/>
+          <a:p>
+            <a:pPr indent="0" marL="0">
+              <a:buNone/>
+            </a:pPr>
+            <a:r>
+              <a:rPr lang="en-US" sz="850" dirty="0">
+                <a:solidFill>
+                  <a:srgbClr val="FFFFFF"/>
+                </a:solidFill>
+                <a:latin typeface="Calibri" pitchFamily="34" charset="0"/>
+                <a:ea typeface="Calibri" pitchFamily="34" charset="-122"/>
+                <a:cs typeface="Calibri" pitchFamily="34" charset="-120"/>
+              </a:rPr>
+              <a:t>BIMGUARD AI  |  Final Master Project  |  Zigurat Global Institute of Technology  |  Group 5</a:t>
+            </a:r>
+            <a:endParaRPr lang="en-US" sz="850" dirty="0"/>
+          </a:p>
+        </p:txBody>
+      </p:sp>
+    </p:spTree>
+  </p:cSld>
+  <p:clrMapOvr>
+    <a:masterClrMapping/>
+  </p:clrMapOvr>
+</p:sld>
+</file>
+
+<file path=ppt/slides/slide21.xml><?xml version="1.0" encoding="utf-8"?>
+<p:sld xmlns:a="http://schemas.openxmlformats.org/drawingml/2006/main" xmlns:r="http://schemas.openxmlformats.org/officeDocument/2006/relationships" xmlns:p="http://schemas.openxmlformats.org/presentationml/2006/main">
   <p:cSld name="Slide 20">
     <p:bg>
       <p:bgPr>
@@ -14001,7 +14962,7 @@
 </p:sld>
 </file>
 
-<file path=ppt/slides/slide21.xml><?xml version="1.0" encoding="utf-8"?>
+<file path=ppt/slides/slide22.xml><?xml version="1.0" encoding="utf-8"?>
 <p:sld xmlns:a="http://schemas.openxmlformats.org/drawingml/2006/main" xmlns:r="http://schemas.openxmlformats.org/officeDocument/2006/relationships" xmlns:p="http://schemas.openxmlformats.org/presentationml/2006/main">
   <p:cSld name="Slide 21">
     <p:bg>
@@ -14623,7 +15584,7 @@
 </p:sld>
 </file>
 
-<file path=ppt/slides/slide22.xml><?xml version="1.0" encoding="utf-8"?>
+<file path=ppt/slides/slide23.xml><?xml version="1.0" encoding="utf-8"?>
 <p:sld xmlns:a="http://schemas.openxmlformats.org/drawingml/2006/main" xmlns:r="http://schemas.openxmlformats.org/officeDocument/2006/relationships" xmlns:p="http://schemas.openxmlformats.org/presentationml/2006/main">
   <p:cSld name="Slide 22">
     <p:bg>
@@ -15206,7 +16167,7 @@
 </p:sld>
 </file>
 
-<file path=ppt/slides/slide23.xml><?xml version="1.0" encoding="utf-8"?>
+<file path=ppt/slides/slide24.xml><?xml version="1.0" encoding="utf-8"?>
 <p:sld xmlns:a="http://schemas.openxmlformats.org/drawingml/2006/main" xmlns:r="http://schemas.openxmlformats.org/officeDocument/2006/relationships" xmlns:p="http://schemas.openxmlformats.org/presentationml/2006/main">
   <p:cSld name="Slide 23">
     <p:bg>

</xml_diff>